<commit_message>
feat: render power-platform-2026 revision 08 with fitted diagram labels
- re-render four voices on adapter 10 so the release-path labels fit

🎙️ - Generated by Copilot

Co-authored-by: Copilot <223556219+Copilot@users.noreply.github.com>
</commit_message>
<xml_diff>
--- a/projects/power-platform-2026/release/outputs/deck.pptx
+++ b/projects/power-platform-2026/release/outputs/deck.pptx
@@ -1361,7 +1361,7 @@
                   <a:srgbClr val="BABABA"/>
                 </a:solidFill>
               </a:rPr>
-              <a:t>power-platform-2026-07-am-michael-kokoro-onnx</a:t>
+              <a:t>power-platform-2026-08-am-michael-kokoro-onnx</a:t>
             </a:r>
           </a:p>
         </p:txBody>
@@ -2848,7 +2848,7 @@
                   <a:srgbClr val="BABABA"/>
                 </a:solidFill>
               </a:rPr>
-              <a:t>power-platform-2026-07-am-michael-kokoro-onnx</a:t>
+              <a:t>power-platform-2026-08-am-michael-kokoro-onnx</a:t>
             </a:r>
           </a:p>
         </p:txBody>

</xml_diff>

<commit_message>
feat: regenerate power-platform-2026 with LF-stable release generation
- render four voices so release-verify passes on any checkout

🎙️ - Generated by Copilot

Co-authored-by: Copilot <223556219+Copilot@users.noreply.github.com>
</commit_message>
<xml_diff>
--- a/projects/power-platform-2026/release/outputs/deck.pptx
+++ b/projects/power-platform-2026/release/outputs/deck.pptx
@@ -1361,7 +1361,7 @@
                   <a:srgbClr val="BABABA"/>
                 </a:solidFill>
               </a:rPr>
-              <a:t>power-platform-2026-08-am-michael-kokoro-onnx</a:t>
+              <a:t>power-platform-2026-09-am-michael-kokoro-onnx</a:t>
             </a:r>
           </a:p>
         </p:txBody>
@@ -2848,7 +2848,7 @@
                   <a:srgbClr val="BABABA"/>
                 </a:solidFill>
               </a:rPr>
-              <a:t>power-platform-2026-08-am-michael-kokoro-onnx</a:t>
+              <a:t>power-platform-2026-09-am-michael-kokoro-onnx</a:t>
             </a:r>
           </a:p>
         </p:txBody>

</xml_diff>

<commit_message>
feat: regenerate power-platform-2026 with its brand theme
- render four voices with the brand header band, palette and fonts

🎨 - Generated by Copilot

Co-authored-by: Copilot <223556219+Copilot@users.noreply.github.com>
</commit_message>
<xml_diff>
--- a/projects/power-platform-2026/release/outputs/deck.pptx
+++ b/projects/power-platform-2026/release/outputs/deck.pptx
@@ -18,6 +18,16 @@
     <a:defPPr>
       <a:defRPr lang="en-US"/>
     </a:defPPr>
+    <a:lvl1pPr algn="l" defTabSz="914400" marL="0" indent="0">
+      <a:defRPr sz="1800" kern="1200">
+        <a:solidFill>
+          <a:schemeClr val="tx1"/>
+        </a:solidFill>
+        <a:latin typeface="+mn-lt"/>
+        <a:ea typeface="+mn-ea"/>
+        <a:cs typeface="+mn-cs"/>
+      </a:defRPr>
+    </a:lvl1pPr>
   </p:defaultTextStyle>
 </p:presentation>
 </file>
@@ -1134,7 +1144,7 @@
     <p:bg>
       <p:bgPr>
         <a:solidFill>
-          <a:srgbClr val="0A0A0A"/>
+          <a:srgbClr val="F4F8FC"/>
         </a:solidFill>
         <a:effectLst/>
       </p:bgPr>
@@ -1148,20 +1158,20 @@
       <p:grpSpPr/>
       <p:sp>
         <p:nvSpPr>
-          <p:cNvPr id="2" name="Accent band"/>
+          <p:cNvPr id="2" name="Brand band"/>
           <p:cNvSpPr/>
           <p:nvPr/>
         </p:nvSpPr>
         <p:spPr>
           <a:xfrm>
             <a:off x="0" y="0"/>
-            <a:ext cx="12192000" cy="91440"/>
+            <a:ext cx="12192000" cy="502920"/>
           </a:xfrm>
           <a:prstGeom prst="rect">
             <a:avLst/>
           </a:prstGeom>
           <a:solidFill>
-            <a:srgbClr val="8F62F5"/>
+            <a:srgbClr val="0E1726"/>
           </a:solidFill>
           <a:ln>
             <a:noFill/>
@@ -1170,14 +1180,36 @@
       </p:sp>
       <p:sp>
         <p:nvSpPr>
-          <p:cNvPr id="3" name="Title"/>
-          <p:cNvSpPr txBox="1"/>
-          <p:nvPr/>
-        </p:nvSpPr>
-        <p:spPr>
-          <a:xfrm>
-            <a:off x="685800" y="900000"/>
-            <a:ext cx="10820400" cy="2000000"/>
+          <p:cNvPr id="3" name="Highlight rule"/>
+          <p:cNvSpPr/>
+          <p:nvPr/>
+        </p:nvSpPr>
+        <p:spPr>
+          <a:xfrm>
+            <a:off x="0" y="502920"/>
+            <a:ext cx="12192000" cy="45720"/>
+          </a:xfrm>
+          <a:prstGeom prst="rect">
+            <a:avLst/>
+          </a:prstGeom>
+          <a:solidFill>
+            <a:srgbClr val="B3DAF0"/>
+          </a:solidFill>
+          <a:ln>
+            <a:noFill/>
+          </a:ln>
+        </p:spPr>
+      </p:sp>
+      <p:sp>
+        <p:nvSpPr>
+          <p:cNvPr id="4" name="Deck kicker"/>
+          <p:cNvSpPr txBox="1"/>
+          <p:nvPr/>
+        </p:nvSpPr>
+        <p:spPr>
+          <a:xfrm>
+            <a:off x="685800" y="0"/>
+            <a:ext cx="8400000" cy="502920"/>
           </a:xfrm>
           <a:prstGeom prst="rect">
             <a:avLst/>
@@ -1202,45 +1234,74 @@
               </a:spcAft>
             </a:pPr>
             <a:r>
-              <a:rPr lang="en-US" sz="3600" b="1">
+              <a:rPr lang="en-US" sz="1100" b="1" cap="all" spc="120">
                 <a:solidFill>
                   <a:srgbClr val="FFFFFF"/>
                 </a:solidFill>
               </a:rPr>
-              <a:t>Power Platform ALM:</a:t>
-            </a:r>
-            <a:r>
-              <a:rPr lang="en-US" sz="3600" b="1">
-                <a:solidFill>
-                  <a:srgbClr val="8F62F5"/>
-                </a:solidFill>
-              </a:rPr>
-              <a:t> govern one release path</a:t>
-            </a:r>
-          </a:p>
-        </p:txBody>
-      </p:sp>
-      <p:sp>
-        <p:nvSpPr>
-          <p:cNvPr id="4" name="Summary"/>
-          <p:cNvSpPr txBox="1"/>
-          <p:nvPr/>
-        </p:nvSpPr>
-        <p:spPr>
-          <a:xfrm>
-            <a:off x="685800" y="3000000"/>
-            <a:ext cx="9600000" cy="1400000"/>
-          </a:xfrm>
-          <a:prstGeom prst="rect">
-            <a:avLst/>
-          </a:prstGeom>
-          <a:noFill/>
-          <a:ln>
-            <a:noFill/>
-          </a:ln>
-        </p:spPr>
-        <p:txBody>
-          <a:bodyPr wrap="square" lIns="182880" tIns="91440" rIns="182880" bIns="91440" anchor="t">
+              <a:t>Power Platform ALM</a:t>
+            </a:r>
+          </a:p>
+        </p:txBody>
+      </p:sp>
+      <p:sp>
+        <p:nvSpPr>
+          <p:cNvPr id="5" name="Slide number"/>
+          <p:cNvSpPr txBox="1"/>
+          <p:nvPr/>
+        </p:nvSpPr>
+        <p:spPr>
+          <a:xfrm>
+            <a:off x="9100000" y="0"/>
+            <a:ext cx="2406400" cy="502920"/>
+          </a:xfrm>
+          <a:prstGeom prst="rect">
+            <a:avLst/>
+          </a:prstGeom>
+          <a:noFill/>
+          <a:ln>
+            <a:noFill/>
+          </a:ln>
+        </p:spPr>
+        <p:txBody>
+          <a:bodyPr wrap="square" lIns="182880" tIns="91440" rIns="182880" bIns="91440" anchor="ctr">
+            <a:normAutofit/>
+          </a:bodyPr>
+          <a:lstStyle/>
+          <a:p>
+            <a:pPr algn="r"/>
+            <a:r>
+              <a:rPr lang="en-US" sz="1100" b="1" cap="all" spc="120">
+                <a:solidFill>
+                  <a:srgbClr val="BCBEC2"/>
+                </a:solidFill>
+              </a:rPr>
+              <a:t>1 / 6</a:t>
+            </a:r>
+          </a:p>
+        </p:txBody>
+      </p:sp>
+      <p:sp>
+        <p:nvSpPr>
+          <p:cNvPr id="6" name="Title"/>
+          <p:cNvSpPr txBox="1"/>
+          <p:nvPr/>
+        </p:nvSpPr>
+        <p:spPr>
+          <a:xfrm>
+            <a:off x="685800" y="1100000"/>
+            <a:ext cx="10820400" cy="2000000"/>
+          </a:xfrm>
+          <a:prstGeom prst="rect">
+            <a:avLst/>
+          </a:prstGeom>
+          <a:noFill/>
+          <a:ln>
+            <a:noFill/>
+          </a:ln>
+        </p:spPr>
+        <p:txBody>
+          <a:bodyPr wrap="square" lIns="182880" tIns="91440" rIns="182880" bIns="91440" anchor="ctr">
             <a:normAutofit/>
           </a:bodyPr>
           <a:lstStyle/>
@@ -1254,43 +1315,47 @@
               </a:spcAft>
             </a:pPr>
             <a:r>
-              <a:rPr lang="en-US" sz="1800">
-                <a:solidFill>
-                  <a:srgbClr val="BABABA"/>
-                </a:solidFill>
-              </a:rPr>
-              <a:t>Bottom line: use one ALM path; ship a managed artifact, set target config, move data apart, and do DLP, test, license and approval checks before final go-live.</a:t>
-            </a:r>
-          </a:p>
-        </p:txBody>
-      </p:sp>
-      <p:sp>
-        <p:nvSpPr>
-          <p:cNvPr id="5" name="Decision"/>
-          <p:cNvSpPr/>
-          <p:nvPr/>
-        </p:nvSpPr>
-        <p:spPr>
-          <a:xfrm>
-            <a:off x="685800" y="4500000"/>
-            <a:ext cx="10820400" cy="1000000"/>
-          </a:xfrm>
-          <a:prstGeom prst="roundRect">
-            <a:avLst>
-              <a:gd name="adj" fmla="val 9000"/>
-            </a:avLst>
-          </a:prstGeom>
-          <a:solidFill>
-            <a:srgbClr val="1F1830"/>
-          </a:solidFill>
-          <a:ln w="12700">
-            <a:solidFill>
-              <a:srgbClr val="8F62F5"/>
-            </a:solidFill>
-          </a:ln>
-        </p:spPr>
-        <p:txBody>
-          <a:bodyPr wrap="square" lIns="182880" tIns="91440" rIns="182880" bIns="91440" anchor="ctr">
+              <a:rPr lang="en-US" sz="3600" b="1">
+                <a:solidFill>
+                  <a:srgbClr val="0B121E"/>
+                </a:solidFill>
+                <a:latin typeface="+mj-lt"/>
+              </a:rPr>
+              <a:t>Power Platform ALM:</a:t>
+            </a:r>
+            <a:r>
+              <a:rPr lang="en-US" sz="3600" b="1">
+                <a:solidFill>
+                  <a:srgbClr val="006EC3"/>
+                </a:solidFill>
+                <a:latin typeface="+mj-lt"/>
+              </a:rPr>
+              <a:t> govern one release path</a:t>
+            </a:r>
+          </a:p>
+        </p:txBody>
+      </p:sp>
+      <p:sp>
+        <p:nvSpPr>
+          <p:cNvPr id="7" name="Summary"/>
+          <p:cNvSpPr txBox="1"/>
+          <p:nvPr/>
+        </p:nvSpPr>
+        <p:spPr>
+          <a:xfrm>
+            <a:off x="685800" y="3150000"/>
+            <a:ext cx="9600000" cy="1400000"/>
+          </a:xfrm>
+          <a:prstGeom prst="rect">
+            <a:avLst/>
+          </a:prstGeom>
+          <a:noFill/>
+          <a:ln>
+            <a:noFill/>
+          </a:ln>
+        </p:spPr>
+        <p:txBody>
+          <a:bodyPr wrap="square" lIns="182880" tIns="91440" rIns="182880" bIns="91440" anchor="t">
             <a:normAutofit/>
           </a:bodyPr>
           <a:lstStyle/>
@@ -1304,45 +1369,43 @@
               </a:spcAft>
             </a:pPr>
             <a:r>
-              <a:rPr lang="en-US" sz="1400" b="1">
-                <a:solidFill>
-                  <a:srgbClr val="8F62F5"/>
-                </a:solidFill>
-              </a:rPr>
-              <a:t>DECISION  </a:t>
-            </a:r>
-            <a:r>
-              <a:rPr lang="en-US" sz="1900" b="1">
-                <a:solidFill>
-                  <a:srgbClr val="FFFFFF"/>
-                </a:solidFill>
-              </a:rPr>
-              <a:t>Fund one governed ALM path; ship managed artifacts and move data separately.</a:t>
-            </a:r>
-          </a:p>
-        </p:txBody>
-      </p:sp>
-      <p:sp>
-        <p:nvSpPr>
-          <p:cNvPr id="6" name="Footer"/>
-          <p:cNvSpPr txBox="1"/>
-          <p:nvPr/>
-        </p:nvSpPr>
-        <p:spPr>
-          <a:xfrm>
-            <a:off x="685800" y="6250000"/>
-            <a:ext cx="9400000" cy="420000"/>
-          </a:xfrm>
-          <a:prstGeom prst="rect">
-            <a:avLst/>
-          </a:prstGeom>
-          <a:noFill/>
-          <a:ln>
-            <a:noFill/>
-          </a:ln>
-        </p:spPr>
-        <p:txBody>
-          <a:bodyPr wrap="square" lIns="182880" tIns="91440" rIns="182880" bIns="91440" anchor="t">
+              <a:rPr lang="en-US" sz="1800">
+                <a:solidFill>
+                  <a:srgbClr val="64686E"/>
+                </a:solidFill>
+              </a:rPr>
+              <a:t>Bottom line: use one ALM path; ship a managed artifact, set target config, move data apart, and do DLP, test, license and approval checks before final go-live.</a:t>
+            </a:r>
+          </a:p>
+        </p:txBody>
+      </p:sp>
+      <p:sp>
+        <p:nvSpPr>
+          <p:cNvPr id="8" name="Decision"/>
+          <p:cNvSpPr/>
+          <p:nvPr/>
+        </p:nvSpPr>
+        <p:spPr>
+          <a:xfrm>
+            <a:off x="685800" y="4650000"/>
+            <a:ext cx="10820400" cy="1000000"/>
+          </a:xfrm>
+          <a:prstGeom prst="roundRect">
+            <a:avLst>
+              <a:gd name="adj" fmla="val 6000"/>
+            </a:avLst>
+          </a:prstGeom>
+          <a:solidFill>
+            <a:srgbClr val="F4F9FD"/>
+          </a:solidFill>
+          <a:ln w="12700">
+            <a:solidFill>
+              <a:srgbClr val="6F8795"/>
+            </a:solidFill>
+          </a:ln>
+        </p:spPr>
+        <p:txBody>
+          <a:bodyPr wrap="square" lIns="182880" tIns="91440" rIns="182880" bIns="91440" anchor="ctr">
             <a:normAutofit/>
           </a:bodyPr>
           <a:lstStyle/>
@@ -1356,26 +1419,34 @@
               </a:spcAft>
             </a:pPr>
             <a:r>
-              <a:rPr lang="en-US" sz="1000">
-                <a:solidFill>
-                  <a:srgbClr val="BABABA"/>
-                </a:solidFill>
-              </a:rPr>
-              <a:t>power-platform-2026-09-am-michael-kokoro-onnx</a:t>
-            </a:r>
-          </a:p>
-        </p:txBody>
-      </p:sp>
-      <p:sp>
-        <p:nvSpPr>
-          <p:cNvPr id="7" name="Slide number"/>
-          <p:cNvSpPr txBox="1"/>
-          <p:nvPr/>
-        </p:nvSpPr>
-        <p:spPr>
-          <a:xfrm>
-            <a:off x="10100000" y="6250000"/>
-            <a:ext cx="1400000" cy="420000"/>
+              <a:rPr lang="en-US" sz="1400" b="1">
+                <a:solidFill>
+                  <a:srgbClr val="006EC3"/>
+                </a:solidFill>
+              </a:rPr>
+              <a:t>DECISION  </a:t>
+            </a:r>
+            <a:r>
+              <a:rPr lang="en-US" sz="1900" b="1">
+                <a:solidFill>
+                  <a:srgbClr val="0B121E"/>
+                </a:solidFill>
+              </a:rPr>
+              <a:t>Fund one governed ALM path; ship managed artifacts and move data separately.</a:t>
+            </a:r>
+          </a:p>
+        </p:txBody>
+      </p:sp>
+      <p:sp>
+        <p:nvSpPr>
+          <p:cNvPr id="9" name="Footer"/>
+          <p:cNvSpPr txBox="1"/>
+          <p:nvPr/>
+        </p:nvSpPr>
+        <p:spPr>
+          <a:xfrm>
+            <a:off x="685800" y="6250000"/>
+            <a:ext cx="10820400" cy="420000"/>
           </a:xfrm>
           <a:prstGeom prst="rect">
             <a:avLst/>
@@ -1391,14 +1462,21 @@
           </a:bodyPr>
           <a:lstStyle/>
           <a:p>
-            <a:pPr algn="r"/>
+            <a:pPr algn="l">
+              <a:lnSpc>
+                <a:spcPct val="105000"/>
+              </a:lnSpc>
+              <a:spcAft>
+                <a:spcPts val="0"/>
+              </a:spcAft>
+            </a:pPr>
             <a:r>
               <a:rPr lang="en-US" sz="1000">
                 <a:solidFill>
-                  <a:srgbClr val="BABABA"/>
-                </a:solidFill>
-              </a:rPr>
-              <a:t>1 / 6</a:t>
+                  <a:srgbClr val="64686E"/>
+                </a:solidFill>
+              </a:rPr>
+              <a:t>power-platform-2026-10-am-michael-kokoro-onnx</a:t>
             </a:r>
           </a:p>
         </p:txBody>
@@ -1417,7 +1495,7 @@
     <p:bg>
       <p:bgPr>
         <a:solidFill>
-          <a:srgbClr val="0A0A0A"/>
+          <a:srgbClr val="F4F8FC"/>
         </a:solidFill>
         <a:effectLst/>
       </p:bgPr>
@@ -1431,20 +1509,20 @@
       <p:grpSpPr/>
       <p:sp>
         <p:nvSpPr>
-          <p:cNvPr id="2" name="Accent band"/>
+          <p:cNvPr id="2" name="Brand band"/>
           <p:cNvSpPr/>
           <p:nvPr/>
         </p:nvSpPr>
         <p:spPr>
           <a:xfrm>
             <a:off x="0" y="0"/>
-            <a:ext cx="12192000" cy="91440"/>
+            <a:ext cx="12192000" cy="502920"/>
           </a:xfrm>
           <a:prstGeom prst="rect">
             <a:avLst/>
           </a:prstGeom>
           <a:solidFill>
-            <a:srgbClr val="8F62F5"/>
+            <a:srgbClr val="0E1726"/>
           </a:solidFill>
           <a:ln>
             <a:noFill/>
@@ -1453,14 +1531,36 @@
       </p:sp>
       <p:sp>
         <p:nvSpPr>
-          <p:cNvPr id="3" name="Title"/>
-          <p:cNvSpPr txBox="1"/>
-          <p:nvPr/>
-        </p:nvSpPr>
-        <p:spPr>
-          <a:xfrm>
-            <a:off x="685800" y="420000"/>
-            <a:ext cx="10820400" cy="1150000"/>
+          <p:cNvPr id="3" name="Highlight rule"/>
+          <p:cNvSpPr/>
+          <p:nvPr/>
+        </p:nvSpPr>
+        <p:spPr>
+          <a:xfrm>
+            <a:off x="0" y="502920"/>
+            <a:ext cx="12192000" cy="45720"/>
+          </a:xfrm>
+          <a:prstGeom prst="rect">
+            <a:avLst/>
+          </a:prstGeom>
+          <a:solidFill>
+            <a:srgbClr val="B3DAF0"/>
+          </a:solidFill>
+          <a:ln>
+            <a:noFill/>
+          </a:ln>
+        </p:spPr>
+      </p:sp>
+      <p:sp>
+        <p:nvSpPr>
+          <p:cNvPr id="4" name="Deck kicker"/>
+          <p:cNvSpPr txBox="1"/>
+          <p:nvPr/>
+        </p:nvSpPr>
+        <p:spPr>
+          <a:xfrm>
+            <a:off x="685800" y="0"/>
+            <a:ext cx="8400000" cy="502920"/>
           </a:xfrm>
           <a:prstGeom prst="rect">
             <a:avLst/>
@@ -1485,45 +1585,74 @@
               </a:spcAft>
             </a:pPr>
             <a:r>
-              <a:rPr lang="en-US" sz="2900" b="1">
+              <a:rPr lang="en-US" sz="1100" b="1" cap="all" spc="120">
                 <a:solidFill>
                   <a:srgbClr val="FFFFFF"/>
                 </a:solidFill>
               </a:rPr>
-              <a:t>1.</a:t>
-            </a:r>
-            <a:r>
-              <a:rPr lang="en-US" sz="2900" b="1">
-                <a:solidFill>
-                  <a:srgbClr val="8F62F5"/>
-                </a:solidFill>
-              </a:rPr>
-              <a:t> One platform</a:t>
-            </a:r>
-          </a:p>
-        </p:txBody>
-      </p:sp>
-      <p:sp>
-        <p:nvSpPr>
-          <p:cNvPr id="4" name="Body"/>
-          <p:cNvSpPr txBox="1"/>
-          <p:nvPr/>
-        </p:nvSpPr>
-        <p:spPr>
-          <a:xfrm>
-            <a:off x="685800" y="1750000"/>
-            <a:ext cx="3900000" cy="3900000"/>
-          </a:xfrm>
-          <a:prstGeom prst="rect">
-            <a:avLst/>
-          </a:prstGeom>
-          <a:noFill/>
-          <a:ln>
-            <a:noFill/>
-          </a:ln>
-        </p:spPr>
-        <p:txBody>
-          <a:bodyPr wrap="square" lIns="182880" tIns="91440" rIns="182880" bIns="91440" anchor="t">
+              <a:t>Power Platform ALM</a:t>
+            </a:r>
+          </a:p>
+        </p:txBody>
+      </p:sp>
+      <p:sp>
+        <p:nvSpPr>
+          <p:cNvPr id="5" name="Slide number"/>
+          <p:cNvSpPr txBox="1"/>
+          <p:nvPr/>
+        </p:nvSpPr>
+        <p:spPr>
+          <a:xfrm>
+            <a:off x="9100000" y="0"/>
+            <a:ext cx="2406400" cy="502920"/>
+          </a:xfrm>
+          <a:prstGeom prst="rect">
+            <a:avLst/>
+          </a:prstGeom>
+          <a:noFill/>
+          <a:ln>
+            <a:noFill/>
+          </a:ln>
+        </p:spPr>
+        <p:txBody>
+          <a:bodyPr wrap="square" lIns="182880" tIns="91440" rIns="182880" bIns="91440" anchor="ctr">
+            <a:normAutofit/>
+          </a:bodyPr>
+          <a:lstStyle/>
+          <a:p>
+            <a:pPr algn="r"/>
+            <a:r>
+              <a:rPr lang="en-US" sz="1100" b="1" cap="all" spc="120">
+                <a:solidFill>
+                  <a:srgbClr val="BCBEC2"/>
+                </a:solidFill>
+              </a:rPr>
+              <a:t>2 / 6</a:t>
+            </a:r>
+          </a:p>
+        </p:txBody>
+      </p:sp>
+      <p:sp>
+        <p:nvSpPr>
+          <p:cNvPr id="6" name="Title"/>
+          <p:cNvSpPr txBox="1"/>
+          <p:nvPr/>
+        </p:nvSpPr>
+        <p:spPr>
+          <a:xfrm>
+            <a:off x="685800" y="700000"/>
+            <a:ext cx="10820400" cy="1150000"/>
+          </a:xfrm>
+          <a:prstGeom prst="rect">
+            <a:avLst/>
+          </a:prstGeom>
+          <a:noFill/>
+          <a:ln>
+            <a:noFill/>
+          </a:ln>
+        </p:spPr>
+        <p:txBody>
+          <a:bodyPr wrap="square" lIns="182880" tIns="91440" rIns="182880" bIns="91440" anchor="ctr">
             <a:normAutofit/>
           </a:bodyPr>
           <a:lstStyle/>
@@ -1537,77 +1666,36 @@
               </a:spcAft>
             </a:pPr>
             <a:r>
-              <a:rPr lang="en-US" sz="2400">
-                <a:solidFill>
-                  <a:srgbClr val="FFFFFF"/>
-                </a:solidFill>
-              </a:rPr>
-              <a:t>Treat the suite as one platform for apps, flows, sites, agents and Dataverse data. Put lifecycle, security, test and release choices in one clear decision frame.</a:t>
-            </a:r>
-          </a:p>
-        </p:txBody>
-      </p:sp>
-      <p:sp>
-        <p:nvSpPr>
-          <p:cNvPr id="5" name="Accent rule"/>
-          <p:cNvSpPr/>
-          <p:nvPr/>
-        </p:nvSpPr>
-        <p:spPr>
-          <a:xfrm>
-            <a:off x="548640" y="1800000"/>
-            <a:ext cx="45720" cy="3800000"/>
-          </a:xfrm>
-          <a:prstGeom prst="rect">
-            <a:avLst/>
-          </a:prstGeom>
-          <a:solidFill>
-            <a:srgbClr val="8F62F5"/>
-          </a:solidFill>
-          <a:ln>
-            <a:noFill/>
-          </a:ln>
-        </p:spPr>
-      </p:sp>
-      <p:pic>
-        <p:nvPicPr>
-          <p:cNvPr id="6" name="Asset visual-one-platform" descr="The decision frame is one governed ALM path across the Power Platform suite. (mermaid diagram)"/>
-          <p:cNvPicPr>
-            <a:picLocks noChangeAspect="1"/>
-          </p:cNvPicPr>
-          <p:nvPr/>
-        </p:nvPicPr>
-        <p:blipFill>
-          <a:blip r:embed="rIdImage1"/>
-          <a:stretch>
-            <a:fillRect/>
-          </a:stretch>
-        </p:blipFill>
-        <p:spPr>
-          <a:xfrm>
-            <a:off x="5000000" y="2021875"/>
-            <a:ext cx="6500000" cy="3656250"/>
-          </a:xfrm>
-          <a:prstGeom prst="rect">
-            <a:avLst/>
-          </a:prstGeom>
-          <a:ln>
-            <a:solidFill>
-              <a:srgbClr val="D9D9D9"/>
-            </a:solidFill>
-          </a:ln>
-        </p:spPr>
-      </p:pic>
-      <p:sp>
-        <p:nvSpPr>
-          <p:cNvPr id="7" name="Footer"/>
-          <p:cNvSpPr txBox="1"/>
-          <p:nvPr/>
-        </p:nvSpPr>
-        <p:spPr>
-          <a:xfrm>
-            <a:off x="685800" y="6250000"/>
-            <a:ext cx="9400000" cy="420000"/>
+              <a:rPr lang="en-US" sz="2900" b="1">
+                <a:solidFill>
+                  <a:srgbClr val="0B121E"/>
+                </a:solidFill>
+                <a:latin typeface="+mj-lt"/>
+              </a:rPr>
+              <a:t>1.</a:t>
+            </a:r>
+            <a:r>
+              <a:rPr lang="en-US" sz="2900" b="1">
+                <a:solidFill>
+                  <a:srgbClr val="006EC3"/>
+                </a:solidFill>
+                <a:latin typeface="+mj-lt"/>
+              </a:rPr>
+              <a:t> One platform</a:t>
+            </a:r>
+          </a:p>
+        </p:txBody>
+      </p:sp>
+      <p:sp>
+        <p:nvSpPr>
+          <p:cNvPr id="7" name="Body"/>
+          <p:cNvSpPr txBox="1"/>
+          <p:nvPr/>
+        </p:nvSpPr>
+        <p:spPr>
+          <a:xfrm>
+            <a:off x="685800" y="1950000"/>
+            <a:ext cx="3900000" cy="3900000"/>
           </a:xfrm>
           <a:prstGeom prst="rect">
             <a:avLst/>
@@ -1632,26 +1720,77 @@
               </a:spcAft>
             </a:pPr>
             <a:r>
-              <a:rPr lang="en-US" sz="1000">
-                <a:solidFill>
-                  <a:srgbClr val="BABABA"/>
-                </a:solidFill>
-              </a:rPr>
-              <a:t>Sources: Overview of application lifecycle management with Microsoft Power Platform</a:t>
-            </a:r>
-          </a:p>
-        </p:txBody>
-      </p:sp>
-      <p:sp>
-        <p:nvSpPr>
-          <p:cNvPr id="8" name="Slide number"/>
-          <p:cNvSpPr txBox="1"/>
-          <p:nvPr/>
-        </p:nvSpPr>
-        <p:spPr>
-          <a:xfrm>
-            <a:off x="10100000" y="6250000"/>
-            <a:ext cx="1400000" cy="420000"/>
+              <a:rPr lang="en-US" sz="2400">
+                <a:solidFill>
+                  <a:srgbClr val="0B121E"/>
+                </a:solidFill>
+              </a:rPr>
+              <a:t>Treat the suite as one platform for apps, flows, sites, agents and Dataverse data. Put lifecycle, security, test and release choices in one clear decision frame.</a:t>
+            </a:r>
+          </a:p>
+        </p:txBody>
+      </p:sp>
+      <p:sp>
+        <p:nvSpPr>
+          <p:cNvPr id="8" name="Accent rule"/>
+          <p:cNvSpPr/>
+          <p:nvPr/>
+        </p:nvSpPr>
+        <p:spPr>
+          <a:xfrm>
+            <a:off x="548640" y="2000000"/>
+            <a:ext cx="45720" cy="3800000"/>
+          </a:xfrm>
+          <a:prstGeom prst="rect">
+            <a:avLst/>
+          </a:prstGeom>
+          <a:solidFill>
+            <a:srgbClr val="006EC3"/>
+          </a:solidFill>
+          <a:ln>
+            <a:noFill/>
+          </a:ln>
+        </p:spPr>
+      </p:sp>
+      <p:pic>
+        <p:nvPicPr>
+          <p:cNvPr id="9" name="Asset visual-one-platform" descr="The decision frame is one governed ALM path across the Power Platform suite. (mermaid diagram)"/>
+          <p:cNvPicPr>
+            <a:picLocks noChangeAspect="1"/>
+          </p:cNvPicPr>
+          <p:nvPr/>
+        </p:nvPicPr>
+        <p:blipFill>
+          <a:blip r:embed="rIdImage1"/>
+          <a:stretch>
+            <a:fillRect/>
+          </a:stretch>
+        </p:blipFill>
+        <p:spPr>
+          <a:xfrm>
+            <a:off x="5000000" y="2221875"/>
+            <a:ext cx="6500000" cy="3656250"/>
+          </a:xfrm>
+          <a:prstGeom prst="rect">
+            <a:avLst/>
+          </a:prstGeom>
+          <a:ln>
+            <a:solidFill>
+              <a:srgbClr val="D9D9D9"/>
+            </a:solidFill>
+          </a:ln>
+        </p:spPr>
+      </p:pic>
+      <p:sp>
+        <p:nvSpPr>
+          <p:cNvPr id="10" name="Footer"/>
+          <p:cNvSpPr txBox="1"/>
+          <p:nvPr/>
+        </p:nvSpPr>
+        <p:spPr>
+          <a:xfrm>
+            <a:off x="685800" y="6250000"/>
+            <a:ext cx="10820400" cy="420000"/>
           </a:xfrm>
           <a:prstGeom prst="rect">
             <a:avLst/>
@@ -1667,14 +1806,21 @@
           </a:bodyPr>
           <a:lstStyle/>
           <a:p>
-            <a:pPr algn="r"/>
+            <a:pPr algn="l">
+              <a:lnSpc>
+                <a:spcPct val="105000"/>
+              </a:lnSpc>
+              <a:spcAft>
+                <a:spcPts val="0"/>
+              </a:spcAft>
+            </a:pPr>
             <a:r>
               <a:rPr lang="en-US" sz="1000">
                 <a:solidFill>
-                  <a:srgbClr val="BABABA"/>
-                </a:solidFill>
-              </a:rPr>
-              <a:t>2 / 6</a:t>
+                  <a:srgbClr val="64686E"/>
+                </a:solidFill>
+              </a:rPr>
+              <a:t>Sources: Overview of application lifecycle management with Microsoft Power Platform</a:t>
             </a:r>
           </a:p>
         </p:txBody>
@@ -1693,7 +1839,7 @@
     <p:bg>
       <p:bgPr>
         <a:solidFill>
-          <a:srgbClr val="0A0A0A"/>
+          <a:srgbClr val="F4F8FC"/>
         </a:solidFill>
         <a:effectLst/>
       </p:bgPr>
@@ -1707,20 +1853,20 @@
       <p:grpSpPr/>
       <p:sp>
         <p:nvSpPr>
-          <p:cNvPr id="2" name="Accent band"/>
+          <p:cNvPr id="2" name="Brand band"/>
           <p:cNvSpPr/>
           <p:nvPr/>
         </p:nvSpPr>
         <p:spPr>
           <a:xfrm>
             <a:off x="0" y="0"/>
-            <a:ext cx="12192000" cy="91440"/>
+            <a:ext cx="12192000" cy="502920"/>
           </a:xfrm>
           <a:prstGeom prst="rect">
             <a:avLst/>
           </a:prstGeom>
           <a:solidFill>
-            <a:srgbClr val="8F62F5"/>
+            <a:srgbClr val="0E1726"/>
           </a:solidFill>
           <a:ln>
             <a:noFill/>
@@ -1729,14 +1875,36 @@
       </p:sp>
       <p:sp>
         <p:nvSpPr>
-          <p:cNvPr id="3" name="Title"/>
-          <p:cNvSpPr txBox="1"/>
-          <p:nvPr/>
-        </p:nvSpPr>
-        <p:spPr>
-          <a:xfrm>
-            <a:off x="685800" y="420000"/>
-            <a:ext cx="10820400" cy="1150000"/>
+          <p:cNvPr id="3" name="Highlight rule"/>
+          <p:cNvSpPr/>
+          <p:nvPr/>
+        </p:nvSpPr>
+        <p:spPr>
+          <a:xfrm>
+            <a:off x="0" y="502920"/>
+            <a:ext cx="12192000" cy="45720"/>
+          </a:xfrm>
+          <a:prstGeom prst="rect">
+            <a:avLst/>
+          </a:prstGeom>
+          <a:solidFill>
+            <a:srgbClr val="B3DAF0"/>
+          </a:solidFill>
+          <a:ln>
+            <a:noFill/>
+          </a:ln>
+        </p:spPr>
+      </p:sp>
+      <p:sp>
+        <p:nvSpPr>
+          <p:cNvPr id="4" name="Deck kicker"/>
+          <p:cNvSpPr txBox="1"/>
+          <p:nvPr/>
+        </p:nvSpPr>
+        <p:spPr>
+          <a:xfrm>
+            <a:off x="685800" y="0"/>
+            <a:ext cx="8400000" cy="502920"/>
           </a:xfrm>
           <a:prstGeom prst="rect">
             <a:avLst/>
@@ -1761,45 +1929,74 @@
               </a:spcAft>
             </a:pPr>
             <a:r>
-              <a:rPr lang="en-US" sz="2900" b="1">
+              <a:rPr lang="en-US" sz="1100" b="1" cap="all" spc="120">
                 <a:solidFill>
                   <a:srgbClr val="FFFFFF"/>
                 </a:solidFill>
               </a:rPr>
-              <a:t>2.</a:t>
-            </a:r>
-            <a:r>
-              <a:rPr lang="en-US" sz="2900" b="1">
-                <a:solidFill>
-                  <a:srgbClr val="8F62F5"/>
-                </a:solidFill>
-              </a:rPr>
-              <a:t> Managed artifact</a:t>
-            </a:r>
-          </a:p>
-        </p:txBody>
-      </p:sp>
-      <p:sp>
-        <p:nvSpPr>
-          <p:cNvPr id="4" name="Body"/>
-          <p:cNvSpPr txBox="1"/>
-          <p:nvPr/>
-        </p:nvSpPr>
-        <p:spPr>
-          <a:xfrm>
-            <a:off x="685800" y="1750000"/>
-            <a:ext cx="3900000" cy="3900000"/>
-          </a:xfrm>
-          <a:prstGeom prst="rect">
-            <a:avLst/>
-          </a:prstGeom>
-          <a:noFill/>
-          <a:ln>
-            <a:noFill/>
-          </a:ln>
-        </p:spPr>
-        <p:txBody>
-          <a:bodyPr wrap="square" lIns="182880" tIns="91440" rIns="182880" bIns="91440" anchor="t">
+              <a:t>Power Platform ALM</a:t>
+            </a:r>
+          </a:p>
+        </p:txBody>
+      </p:sp>
+      <p:sp>
+        <p:nvSpPr>
+          <p:cNvPr id="5" name="Slide number"/>
+          <p:cNvSpPr txBox="1"/>
+          <p:nvPr/>
+        </p:nvSpPr>
+        <p:spPr>
+          <a:xfrm>
+            <a:off x="9100000" y="0"/>
+            <a:ext cx="2406400" cy="502920"/>
+          </a:xfrm>
+          <a:prstGeom prst="rect">
+            <a:avLst/>
+          </a:prstGeom>
+          <a:noFill/>
+          <a:ln>
+            <a:noFill/>
+          </a:ln>
+        </p:spPr>
+        <p:txBody>
+          <a:bodyPr wrap="square" lIns="182880" tIns="91440" rIns="182880" bIns="91440" anchor="ctr">
+            <a:normAutofit/>
+          </a:bodyPr>
+          <a:lstStyle/>
+          <a:p>
+            <a:pPr algn="r"/>
+            <a:r>
+              <a:rPr lang="en-US" sz="1100" b="1" cap="all" spc="120">
+                <a:solidFill>
+                  <a:srgbClr val="BCBEC2"/>
+                </a:solidFill>
+              </a:rPr>
+              <a:t>3 / 6</a:t>
+            </a:r>
+          </a:p>
+        </p:txBody>
+      </p:sp>
+      <p:sp>
+        <p:nvSpPr>
+          <p:cNvPr id="6" name="Title"/>
+          <p:cNvSpPr txBox="1"/>
+          <p:nvPr/>
+        </p:nvSpPr>
+        <p:spPr>
+          <a:xfrm>
+            <a:off x="685800" y="700000"/>
+            <a:ext cx="10820400" cy="1150000"/>
+          </a:xfrm>
+          <a:prstGeom prst="rect">
+            <a:avLst/>
+          </a:prstGeom>
+          <a:noFill/>
+          <a:ln>
+            <a:noFill/>
+          </a:ln>
+        </p:spPr>
+        <p:txBody>
+          <a:bodyPr wrap="square" lIns="182880" tIns="91440" rIns="182880" bIns="91440" anchor="ctr">
             <a:normAutofit/>
           </a:bodyPr>
           <a:lstStyle/>
@@ -1813,77 +2010,36 @@
               </a:spcAft>
             </a:pPr>
             <a:r>
-              <a:rPr lang="en-US" sz="2400">
-                <a:solidFill>
-                  <a:srgbClr val="FFFFFF"/>
-                </a:solidFill>
-              </a:rPr>
-              <a:t>Build change in an unmanaged solution, with source control as the source of truth. Export a managed solution as the build artifact that test and production receive.</a:t>
-            </a:r>
-          </a:p>
-        </p:txBody>
-      </p:sp>
-      <p:sp>
-        <p:nvSpPr>
-          <p:cNvPr id="5" name="Accent rule"/>
-          <p:cNvSpPr/>
-          <p:nvPr/>
-        </p:nvSpPr>
-        <p:spPr>
-          <a:xfrm>
-            <a:off x="548640" y="1800000"/>
-            <a:ext cx="45720" cy="3800000"/>
-          </a:xfrm>
-          <a:prstGeom prst="rect">
-            <a:avLst/>
-          </a:prstGeom>
-          <a:solidFill>
-            <a:srgbClr val="8F62F5"/>
-          </a:solidFill>
-          <a:ln>
-            <a:noFill/>
-          </a:ln>
-        </p:spPr>
-      </p:sp>
-      <p:pic>
-        <p:nvPicPr>
-          <p:cNvPr id="6" name="Asset visual-managed-artifact" descr="Development remains editable, while the promoted package becomes the controlled artifact. (excalidraw diagram)"/>
-          <p:cNvPicPr>
-            <a:picLocks noChangeAspect="1"/>
-          </p:cNvPicPr>
-          <p:nvPr/>
-        </p:nvPicPr>
-        <p:blipFill>
-          <a:blip r:embed="rIdImage1"/>
-          <a:stretch>
-            <a:fillRect/>
-          </a:stretch>
-        </p:blipFill>
-        <p:spPr>
-          <a:xfrm>
-            <a:off x="5000000" y="2021875"/>
-            <a:ext cx="6500000" cy="3656250"/>
-          </a:xfrm>
-          <a:prstGeom prst="rect">
-            <a:avLst/>
-          </a:prstGeom>
-          <a:ln>
-            <a:solidFill>
-              <a:srgbClr val="D9D9D9"/>
-            </a:solidFill>
-          </a:ln>
-        </p:spPr>
-      </p:pic>
-      <p:sp>
-        <p:nvSpPr>
-          <p:cNvPr id="7" name="Footer"/>
-          <p:cNvSpPr txBox="1"/>
-          <p:nvPr/>
-        </p:nvSpPr>
-        <p:spPr>
-          <a:xfrm>
-            <a:off x="685800" y="6250000"/>
-            <a:ext cx="9400000" cy="420000"/>
+              <a:rPr lang="en-US" sz="2900" b="1">
+                <a:solidFill>
+                  <a:srgbClr val="0B121E"/>
+                </a:solidFill>
+                <a:latin typeface="+mj-lt"/>
+              </a:rPr>
+              <a:t>2.</a:t>
+            </a:r>
+            <a:r>
+              <a:rPr lang="en-US" sz="2900" b="1">
+                <a:solidFill>
+                  <a:srgbClr val="006EC3"/>
+                </a:solidFill>
+                <a:latin typeface="+mj-lt"/>
+              </a:rPr>
+              <a:t> Managed artifact</a:t>
+            </a:r>
+          </a:p>
+        </p:txBody>
+      </p:sp>
+      <p:sp>
+        <p:nvSpPr>
+          <p:cNvPr id="7" name="Body"/>
+          <p:cNvSpPr txBox="1"/>
+          <p:nvPr/>
+        </p:nvSpPr>
+        <p:spPr>
+          <a:xfrm>
+            <a:off x="685800" y="1950000"/>
+            <a:ext cx="3900000" cy="3900000"/>
           </a:xfrm>
           <a:prstGeom prst="rect">
             <a:avLst/>
@@ -1908,26 +2064,77 @@
               </a:spcAft>
             </a:pPr>
             <a:r>
-              <a:rPr lang="en-US" sz="1000">
-                <a:solidFill>
-                  <a:srgbClr val="BABABA"/>
-                </a:solidFill>
-              </a:rPr>
-              <a:t>Sources: Overview of application lifecycle management with Microsoft Power Platform  ·  Solution concepts</a:t>
-            </a:r>
-          </a:p>
-        </p:txBody>
-      </p:sp>
-      <p:sp>
-        <p:nvSpPr>
-          <p:cNvPr id="8" name="Slide number"/>
-          <p:cNvSpPr txBox="1"/>
-          <p:nvPr/>
-        </p:nvSpPr>
-        <p:spPr>
-          <a:xfrm>
-            <a:off x="10100000" y="6250000"/>
-            <a:ext cx="1400000" cy="420000"/>
+              <a:rPr lang="en-US" sz="2400">
+                <a:solidFill>
+                  <a:srgbClr val="0B121E"/>
+                </a:solidFill>
+              </a:rPr>
+              <a:t>Build change in an unmanaged solution, with source control as the source of truth. Export a managed solution as the build artifact that test and production receive.</a:t>
+            </a:r>
+          </a:p>
+        </p:txBody>
+      </p:sp>
+      <p:sp>
+        <p:nvSpPr>
+          <p:cNvPr id="8" name="Accent rule"/>
+          <p:cNvSpPr/>
+          <p:nvPr/>
+        </p:nvSpPr>
+        <p:spPr>
+          <a:xfrm>
+            <a:off x="548640" y="2000000"/>
+            <a:ext cx="45720" cy="3800000"/>
+          </a:xfrm>
+          <a:prstGeom prst="rect">
+            <a:avLst/>
+          </a:prstGeom>
+          <a:solidFill>
+            <a:srgbClr val="006EC3"/>
+          </a:solidFill>
+          <a:ln>
+            <a:noFill/>
+          </a:ln>
+        </p:spPr>
+      </p:sp>
+      <p:pic>
+        <p:nvPicPr>
+          <p:cNvPr id="9" name="Asset visual-managed-artifact" descr="Development remains editable, while the promoted package becomes the controlled artifact. (excalidraw diagram)"/>
+          <p:cNvPicPr>
+            <a:picLocks noChangeAspect="1"/>
+          </p:cNvPicPr>
+          <p:nvPr/>
+        </p:nvPicPr>
+        <p:blipFill>
+          <a:blip r:embed="rIdImage1"/>
+          <a:stretch>
+            <a:fillRect/>
+          </a:stretch>
+        </p:blipFill>
+        <p:spPr>
+          <a:xfrm>
+            <a:off x="5000000" y="2221875"/>
+            <a:ext cx="6500000" cy="3656250"/>
+          </a:xfrm>
+          <a:prstGeom prst="rect">
+            <a:avLst/>
+          </a:prstGeom>
+          <a:ln>
+            <a:solidFill>
+              <a:srgbClr val="D9D9D9"/>
+            </a:solidFill>
+          </a:ln>
+        </p:spPr>
+      </p:pic>
+      <p:sp>
+        <p:nvSpPr>
+          <p:cNvPr id="10" name="Footer"/>
+          <p:cNvSpPr txBox="1"/>
+          <p:nvPr/>
+        </p:nvSpPr>
+        <p:spPr>
+          <a:xfrm>
+            <a:off x="685800" y="6250000"/>
+            <a:ext cx="10820400" cy="420000"/>
           </a:xfrm>
           <a:prstGeom prst="rect">
             <a:avLst/>
@@ -1943,14 +2150,21 @@
           </a:bodyPr>
           <a:lstStyle/>
           <a:p>
-            <a:pPr algn="r"/>
+            <a:pPr algn="l">
+              <a:lnSpc>
+                <a:spcPct val="105000"/>
+              </a:lnSpc>
+              <a:spcAft>
+                <a:spcPts val="0"/>
+              </a:spcAft>
+            </a:pPr>
             <a:r>
               <a:rPr lang="en-US" sz="1000">
                 <a:solidFill>
-                  <a:srgbClr val="BABABA"/>
-                </a:solidFill>
-              </a:rPr>
-              <a:t>3 / 6</a:t>
+                  <a:srgbClr val="64686E"/>
+                </a:solidFill>
+              </a:rPr>
+              <a:t>Sources: Overview of application lifecycle management with Microsoft Power Platform  ·  Solution concepts</a:t>
             </a:r>
           </a:p>
         </p:txBody>
@@ -1969,7 +2183,7 @@
     <p:bg>
       <p:bgPr>
         <a:solidFill>
-          <a:srgbClr val="0A0A0A"/>
+          <a:srgbClr val="F4F8FC"/>
         </a:solidFill>
         <a:effectLst/>
       </p:bgPr>
@@ -1983,20 +2197,20 @@
       <p:grpSpPr/>
       <p:sp>
         <p:nvSpPr>
-          <p:cNvPr id="2" name="Accent band"/>
+          <p:cNvPr id="2" name="Brand band"/>
           <p:cNvSpPr/>
           <p:nvPr/>
         </p:nvSpPr>
         <p:spPr>
           <a:xfrm>
             <a:off x="0" y="0"/>
-            <a:ext cx="12192000" cy="91440"/>
+            <a:ext cx="12192000" cy="502920"/>
           </a:xfrm>
           <a:prstGeom prst="rect">
             <a:avLst/>
           </a:prstGeom>
           <a:solidFill>
-            <a:srgbClr val="8F62F5"/>
+            <a:srgbClr val="0E1726"/>
           </a:solidFill>
           <a:ln>
             <a:noFill/>
@@ -2005,14 +2219,36 @@
       </p:sp>
       <p:sp>
         <p:nvSpPr>
-          <p:cNvPr id="3" name="Title"/>
-          <p:cNvSpPr txBox="1"/>
-          <p:nvPr/>
-        </p:nvSpPr>
-        <p:spPr>
-          <a:xfrm>
-            <a:off x="685800" y="420000"/>
-            <a:ext cx="10820400" cy="1150000"/>
+          <p:cNvPr id="3" name="Highlight rule"/>
+          <p:cNvSpPr/>
+          <p:nvPr/>
+        </p:nvSpPr>
+        <p:spPr>
+          <a:xfrm>
+            <a:off x="0" y="502920"/>
+            <a:ext cx="12192000" cy="45720"/>
+          </a:xfrm>
+          <a:prstGeom prst="rect">
+            <a:avLst/>
+          </a:prstGeom>
+          <a:solidFill>
+            <a:srgbClr val="B3DAF0"/>
+          </a:solidFill>
+          <a:ln>
+            <a:noFill/>
+          </a:ln>
+        </p:spPr>
+      </p:sp>
+      <p:sp>
+        <p:nvSpPr>
+          <p:cNvPr id="4" name="Deck kicker"/>
+          <p:cNvSpPr txBox="1"/>
+          <p:nvPr/>
+        </p:nvSpPr>
+        <p:spPr>
+          <a:xfrm>
+            <a:off x="685800" y="0"/>
+            <a:ext cx="8400000" cy="502920"/>
           </a:xfrm>
           <a:prstGeom prst="rect">
             <a:avLst/>
@@ -2037,45 +2273,74 @@
               </a:spcAft>
             </a:pPr>
             <a:r>
-              <a:rPr lang="en-US" sz="2900" b="1">
+              <a:rPr lang="en-US" sz="1100" b="1" cap="all" spc="120">
                 <a:solidFill>
                   <a:srgbClr val="FFFFFF"/>
                 </a:solidFill>
               </a:rPr>
-              <a:t>3.</a:t>
-            </a:r>
-            <a:r>
-              <a:rPr lang="en-US" sz="2900" b="1">
-                <a:solidFill>
-                  <a:srgbClr val="8F62F5"/>
-                </a:solidFill>
-              </a:rPr>
-              <a:t> Config and data</a:t>
-            </a:r>
-          </a:p>
-        </p:txBody>
-      </p:sp>
-      <p:sp>
-        <p:nvSpPr>
-          <p:cNvPr id="4" name="Body"/>
-          <p:cNvSpPr txBox="1"/>
-          <p:nvPr/>
-        </p:nvSpPr>
-        <p:spPr>
-          <a:xfrm>
-            <a:off x="685800" y="1750000"/>
-            <a:ext cx="3900000" cy="3900000"/>
-          </a:xfrm>
-          <a:prstGeom prst="rect">
-            <a:avLst/>
-          </a:prstGeom>
-          <a:noFill/>
-          <a:ln>
-            <a:noFill/>
-          </a:ln>
-        </p:spPr>
-        <p:txBody>
-          <a:bodyPr wrap="square" lIns="182880" tIns="91440" rIns="182880" bIns="91440" anchor="t">
+              <a:t>Power Platform ALM</a:t>
+            </a:r>
+          </a:p>
+        </p:txBody>
+      </p:sp>
+      <p:sp>
+        <p:nvSpPr>
+          <p:cNvPr id="5" name="Slide number"/>
+          <p:cNvSpPr txBox="1"/>
+          <p:nvPr/>
+        </p:nvSpPr>
+        <p:spPr>
+          <a:xfrm>
+            <a:off x="9100000" y="0"/>
+            <a:ext cx="2406400" cy="502920"/>
+          </a:xfrm>
+          <a:prstGeom prst="rect">
+            <a:avLst/>
+          </a:prstGeom>
+          <a:noFill/>
+          <a:ln>
+            <a:noFill/>
+          </a:ln>
+        </p:spPr>
+        <p:txBody>
+          <a:bodyPr wrap="square" lIns="182880" tIns="91440" rIns="182880" bIns="91440" anchor="ctr">
+            <a:normAutofit/>
+          </a:bodyPr>
+          <a:lstStyle/>
+          <a:p>
+            <a:pPr algn="r"/>
+            <a:r>
+              <a:rPr lang="en-US" sz="1100" b="1" cap="all" spc="120">
+                <a:solidFill>
+                  <a:srgbClr val="BCBEC2"/>
+                </a:solidFill>
+              </a:rPr>
+              <a:t>4 / 6</a:t>
+            </a:r>
+          </a:p>
+        </p:txBody>
+      </p:sp>
+      <p:sp>
+        <p:nvSpPr>
+          <p:cNvPr id="6" name="Title"/>
+          <p:cNvSpPr txBox="1"/>
+          <p:nvPr/>
+        </p:nvSpPr>
+        <p:spPr>
+          <a:xfrm>
+            <a:off x="685800" y="700000"/>
+            <a:ext cx="10820400" cy="1150000"/>
+          </a:xfrm>
+          <a:prstGeom prst="rect">
+            <a:avLst/>
+          </a:prstGeom>
+          <a:noFill/>
+          <a:ln>
+            <a:noFill/>
+          </a:ln>
+        </p:spPr>
+        <p:txBody>
+          <a:bodyPr wrap="square" lIns="182880" tIns="91440" rIns="182880" bIns="91440" anchor="ctr">
             <a:normAutofit/>
           </a:bodyPr>
           <a:lstStyle/>
@@ -2089,77 +2354,36 @@
               </a:spcAft>
             </a:pPr>
             <a:r>
-              <a:rPr lang="en-US" sz="2200">
-                <a:solidFill>
-                  <a:srgbClr val="FFFFFF"/>
-                </a:solidFill>
-              </a:rPr>
-              <a:t>Keep configuration and business records on separate tracks. Set connections, references and variables per target, then migrate table rows, because solutions carry no data.</a:t>
-            </a:r>
-          </a:p>
-        </p:txBody>
-      </p:sp>
-      <p:sp>
-        <p:nvSpPr>
-          <p:cNvPr id="5" name="Accent rule"/>
-          <p:cNvSpPr/>
-          <p:nvPr/>
-        </p:nvSpPr>
-        <p:spPr>
-          <a:xfrm>
-            <a:off x="548640" y="1800000"/>
-            <a:ext cx="45720" cy="3800000"/>
-          </a:xfrm>
-          <a:prstGeom prst="rect">
-            <a:avLst/>
-          </a:prstGeom>
-          <a:solidFill>
-            <a:srgbClr val="8F62F5"/>
-          </a:solidFill>
-          <a:ln>
-            <a:noFill/>
-          </a:ln>
-        </p:spPr>
-      </p:sp>
-      <p:pic>
-        <p:nvPicPr>
-          <p:cNvPr id="6" name="Asset visual-config-and-data" descr="Configuration travels with deployment; Dataverse table records need a separate path. (marp diagram)"/>
-          <p:cNvPicPr>
-            <a:picLocks noChangeAspect="1"/>
-          </p:cNvPicPr>
-          <p:nvPr/>
-        </p:nvPicPr>
-        <p:blipFill>
-          <a:blip r:embed="rIdImage1"/>
-          <a:stretch>
-            <a:fillRect/>
-          </a:stretch>
-        </p:blipFill>
-        <p:spPr>
-          <a:xfrm>
-            <a:off x="5000000" y="2021875"/>
-            <a:ext cx="6500000" cy="3656250"/>
-          </a:xfrm>
-          <a:prstGeom prst="rect">
-            <a:avLst/>
-          </a:prstGeom>
-          <a:ln>
-            <a:solidFill>
-              <a:srgbClr val="D9D9D9"/>
-            </a:solidFill>
-          </a:ln>
-        </p:spPr>
-      </p:pic>
-      <p:sp>
-        <p:nvSpPr>
-          <p:cNvPr id="7" name="Footer"/>
-          <p:cNvSpPr txBox="1"/>
-          <p:nvPr/>
-        </p:nvSpPr>
-        <p:spPr>
-          <a:xfrm>
-            <a:off x="685800" y="6250000"/>
-            <a:ext cx="9400000" cy="420000"/>
+              <a:rPr lang="en-US" sz="2900" b="1">
+                <a:solidFill>
+                  <a:srgbClr val="0B121E"/>
+                </a:solidFill>
+                <a:latin typeface="+mj-lt"/>
+              </a:rPr>
+              <a:t>3.</a:t>
+            </a:r>
+            <a:r>
+              <a:rPr lang="en-US" sz="2900" b="1">
+                <a:solidFill>
+                  <a:srgbClr val="006EC3"/>
+                </a:solidFill>
+                <a:latin typeface="+mj-lt"/>
+              </a:rPr>
+              <a:t> Config and data</a:t>
+            </a:r>
+          </a:p>
+        </p:txBody>
+      </p:sp>
+      <p:sp>
+        <p:nvSpPr>
+          <p:cNvPr id="7" name="Body"/>
+          <p:cNvSpPr txBox="1"/>
+          <p:nvPr/>
+        </p:nvSpPr>
+        <p:spPr>
+          <a:xfrm>
+            <a:off x="685800" y="1950000"/>
+            <a:ext cx="3900000" cy="3900000"/>
           </a:xfrm>
           <a:prstGeom prst="rect">
             <a:avLst/>
@@ -2184,26 +2408,77 @@
               </a:spcAft>
             </a:pPr>
             <a:r>
-              <a:rPr lang="en-US" sz="1000">
-                <a:solidFill>
-                  <a:srgbClr val="BABABA"/>
-                </a:solidFill>
-              </a:rPr>
-              <a:t>Sources: Overview of pipelines in Power Platform</a:t>
-            </a:r>
-          </a:p>
-        </p:txBody>
-      </p:sp>
-      <p:sp>
-        <p:nvSpPr>
-          <p:cNvPr id="8" name="Slide number"/>
-          <p:cNvSpPr txBox="1"/>
-          <p:nvPr/>
-        </p:nvSpPr>
-        <p:spPr>
-          <a:xfrm>
-            <a:off x="10100000" y="6250000"/>
-            <a:ext cx="1400000" cy="420000"/>
+              <a:rPr lang="en-US" sz="2200">
+                <a:solidFill>
+                  <a:srgbClr val="0B121E"/>
+                </a:solidFill>
+              </a:rPr>
+              <a:t>Keep configuration and business records on separate tracks. Set connections, references and variables per target, then migrate table rows, because solutions carry no data.</a:t>
+            </a:r>
+          </a:p>
+        </p:txBody>
+      </p:sp>
+      <p:sp>
+        <p:nvSpPr>
+          <p:cNvPr id="8" name="Accent rule"/>
+          <p:cNvSpPr/>
+          <p:nvPr/>
+        </p:nvSpPr>
+        <p:spPr>
+          <a:xfrm>
+            <a:off x="548640" y="2000000"/>
+            <a:ext cx="45720" cy="3800000"/>
+          </a:xfrm>
+          <a:prstGeom prst="rect">
+            <a:avLst/>
+          </a:prstGeom>
+          <a:solidFill>
+            <a:srgbClr val="006EC3"/>
+          </a:solidFill>
+          <a:ln>
+            <a:noFill/>
+          </a:ln>
+        </p:spPr>
+      </p:sp>
+      <p:pic>
+        <p:nvPicPr>
+          <p:cNvPr id="9" name="Asset visual-config-and-data" descr="Configuration travels with deployment; Dataverse table records need a separate path. (marp diagram)"/>
+          <p:cNvPicPr>
+            <a:picLocks noChangeAspect="1"/>
+          </p:cNvPicPr>
+          <p:nvPr/>
+        </p:nvPicPr>
+        <p:blipFill>
+          <a:blip r:embed="rIdImage1"/>
+          <a:stretch>
+            <a:fillRect/>
+          </a:stretch>
+        </p:blipFill>
+        <p:spPr>
+          <a:xfrm>
+            <a:off x="5000000" y="2221875"/>
+            <a:ext cx="6500000" cy="3656250"/>
+          </a:xfrm>
+          <a:prstGeom prst="rect">
+            <a:avLst/>
+          </a:prstGeom>
+          <a:ln>
+            <a:solidFill>
+              <a:srgbClr val="D9D9D9"/>
+            </a:solidFill>
+          </a:ln>
+        </p:spPr>
+      </p:pic>
+      <p:sp>
+        <p:nvSpPr>
+          <p:cNvPr id="10" name="Footer"/>
+          <p:cNvSpPr txBox="1"/>
+          <p:nvPr/>
+        </p:nvSpPr>
+        <p:spPr>
+          <a:xfrm>
+            <a:off x="685800" y="6250000"/>
+            <a:ext cx="10820400" cy="420000"/>
           </a:xfrm>
           <a:prstGeom prst="rect">
             <a:avLst/>
@@ -2219,14 +2494,21 @@
           </a:bodyPr>
           <a:lstStyle/>
           <a:p>
-            <a:pPr algn="r"/>
+            <a:pPr algn="l">
+              <a:lnSpc>
+                <a:spcPct val="105000"/>
+              </a:lnSpc>
+              <a:spcAft>
+                <a:spcPts val="0"/>
+              </a:spcAft>
+            </a:pPr>
             <a:r>
               <a:rPr lang="en-US" sz="1000">
                 <a:solidFill>
-                  <a:srgbClr val="BABABA"/>
-                </a:solidFill>
-              </a:rPr>
-              <a:t>4 / 6</a:t>
+                  <a:srgbClr val="64686E"/>
+                </a:solidFill>
+              </a:rPr>
+              <a:t>Sources: Overview of pipelines in Power Platform</a:t>
             </a:r>
           </a:p>
         </p:txBody>
@@ -2245,7 +2527,7 @@
     <p:bg>
       <p:bgPr>
         <a:solidFill>
-          <a:srgbClr val="0A0A0A"/>
+          <a:srgbClr val="F4F8FC"/>
         </a:solidFill>
         <a:effectLst/>
       </p:bgPr>
@@ -2259,20 +2541,20 @@
       <p:grpSpPr/>
       <p:sp>
         <p:nvSpPr>
-          <p:cNvPr id="2" name="Accent band"/>
+          <p:cNvPr id="2" name="Brand band"/>
           <p:cNvSpPr/>
           <p:nvPr/>
         </p:nvSpPr>
         <p:spPr>
           <a:xfrm>
             <a:off x="0" y="0"/>
-            <a:ext cx="12192000" cy="91440"/>
+            <a:ext cx="12192000" cy="502920"/>
           </a:xfrm>
           <a:prstGeom prst="rect">
             <a:avLst/>
           </a:prstGeom>
           <a:solidFill>
-            <a:srgbClr val="8F62F5"/>
+            <a:srgbClr val="0E1726"/>
           </a:solidFill>
           <a:ln>
             <a:noFill/>
@@ -2281,14 +2563,36 @@
       </p:sp>
       <p:sp>
         <p:nvSpPr>
-          <p:cNvPr id="3" name="Title"/>
-          <p:cNvSpPr txBox="1"/>
-          <p:nvPr/>
-        </p:nvSpPr>
-        <p:spPr>
-          <a:xfrm>
-            <a:off x="685800" y="420000"/>
-            <a:ext cx="10820400" cy="1150000"/>
+          <p:cNvPr id="3" name="Highlight rule"/>
+          <p:cNvSpPr/>
+          <p:nvPr/>
+        </p:nvSpPr>
+        <p:spPr>
+          <a:xfrm>
+            <a:off x="0" y="502920"/>
+            <a:ext cx="12192000" cy="45720"/>
+          </a:xfrm>
+          <a:prstGeom prst="rect">
+            <a:avLst/>
+          </a:prstGeom>
+          <a:solidFill>
+            <a:srgbClr val="B3DAF0"/>
+          </a:solidFill>
+          <a:ln>
+            <a:noFill/>
+          </a:ln>
+        </p:spPr>
+      </p:sp>
+      <p:sp>
+        <p:nvSpPr>
+          <p:cNvPr id="4" name="Deck kicker"/>
+          <p:cNvSpPr txBox="1"/>
+          <p:nvPr/>
+        </p:nvSpPr>
+        <p:spPr>
+          <a:xfrm>
+            <a:off x="685800" y="0"/>
+            <a:ext cx="8400000" cy="502920"/>
           </a:xfrm>
           <a:prstGeom prst="rect">
             <a:avLst/>
@@ -2313,45 +2617,74 @@
               </a:spcAft>
             </a:pPr>
             <a:r>
-              <a:rPr lang="en-US" sz="2900" b="1">
+              <a:rPr lang="en-US" sz="1100" b="1" cap="all" spc="120">
                 <a:solidFill>
                   <a:srgbClr val="FFFFFF"/>
                 </a:solidFill>
               </a:rPr>
-              <a:t>4.</a:t>
-            </a:r>
-            <a:r>
-              <a:rPr lang="en-US" sz="2900" b="1">
-                <a:solidFill>
-                  <a:srgbClr val="8F62F5"/>
-                </a:solidFill>
-              </a:rPr>
-              <a:t> Release gate</a:t>
-            </a:r>
-          </a:p>
-        </p:txBody>
-      </p:sp>
-      <p:sp>
-        <p:nvSpPr>
-          <p:cNvPr id="4" name="Body"/>
-          <p:cNvSpPr txBox="1"/>
-          <p:nvPr/>
-        </p:nvSpPr>
-        <p:spPr>
-          <a:xfrm>
-            <a:off x="685800" y="1750000"/>
-            <a:ext cx="3900000" cy="3900000"/>
-          </a:xfrm>
-          <a:prstGeom prst="rect">
-            <a:avLst/>
-          </a:prstGeom>
-          <a:noFill/>
-          <a:ln>
-            <a:noFill/>
-          </a:ln>
-        </p:spPr>
-        <p:txBody>
-          <a:bodyPr wrap="square" lIns="182880" tIns="91440" rIns="182880" bIns="91440" anchor="t">
+              <a:t>Power Platform ALM</a:t>
+            </a:r>
+          </a:p>
+        </p:txBody>
+      </p:sp>
+      <p:sp>
+        <p:nvSpPr>
+          <p:cNvPr id="5" name="Slide number"/>
+          <p:cNvSpPr txBox="1"/>
+          <p:nvPr/>
+        </p:nvSpPr>
+        <p:spPr>
+          <a:xfrm>
+            <a:off x="9100000" y="0"/>
+            <a:ext cx="2406400" cy="502920"/>
+          </a:xfrm>
+          <a:prstGeom prst="rect">
+            <a:avLst/>
+          </a:prstGeom>
+          <a:noFill/>
+          <a:ln>
+            <a:noFill/>
+          </a:ln>
+        </p:spPr>
+        <p:txBody>
+          <a:bodyPr wrap="square" lIns="182880" tIns="91440" rIns="182880" bIns="91440" anchor="ctr">
+            <a:normAutofit/>
+          </a:bodyPr>
+          <a:lstStyle/>
+          <a:p>
+            <a:pPr algn="r"/>
+            <a:r>
+              <a:rPr lang="en-US" sz="1100" b="1" cap="all" spc="120">
+                <a:solidFill>
+                  <a:srgbClr val="BCBEC2"/>
+                </a:solidFill>
+              </a:rPr>
+              <a:t>5 / 6</a:t>
+            </a:r>
+          </a:p>
+        </p:txBody>
+      </p:sp>
+      <p:sp>
+        <p:nvSpPr>
+          <p:cNvPr id="6" name="Title"/>
+          <p:cNvSpPr txBox="1"/>
+          <p:nvPr/>
+        </p:nvSpPr>
+        <p:spPr>
+          <a:xfrm>
+            <a:off x="685800" y="700000"/>
+            <a:ext cx="10820400" cy="1150000"/>
+          </a:xfrm>
+          <a:prstGeom prst="rect">
+            <a:avLst/>
+          </a:prstGeom>
+          <a:noFill/>
+          <a:ln>
+            <a:noFill/>
+          </a:ln>
+        </p:spPr>
+        <p:txBody>
+          <a:bodyPr wrap="square" lIns="182880" tIns="91440" rIns="182880" bIns="91440" anchor="ctr">
             <a:normAutofit/>
           </a:bodyPr>
           <a:lstStyle/>
@@ -2365,77 +2698,36 @@
               </a:spcAft>
             </a:pPr>
             <a:r>
-              <a:rPr lang="en-US" sz="2400">
-                <a:solidFill>
-                  <a:srgbClr val="FFFFFF"/>
-                </a:solidFill>
-              </a:rPr>
-              <a:t>Automate with pipelines, or use Azure DevOps or GitHub when the route needs it. Before final production, check DLP policy, tests, analytics, approvals and licenses.</a:t>
-            </a:r>
-          </a:p>
-        </p:txBody>
-      </p:sp>
-      <p:sp>
-        <p:nvSpPr>
-          <p:cNvPr id="5" name="Accent rule"/>
-          <p:cNvSpPr/>
-          <p:nvPr/>
-        </p:nvSpPr>
-        <p:spPr>
-          <a:xfrm>
-            <a:off x="548640" y="1800000"/>
-            <a:ext cx="45720" cy="3800000"/>
-          </a:xfrm>
-          <a:prstGeom prst="rect">
-            <a:avLst/>
-          </a:prstGeom>
-          <a:solidFill>
-            <a:srgbClr val="8F62F5"/>
-          </a:solidFill>
-          <a:ln>
-            <a:noFill/>
-          </a:ln>
-        </p:spPr>
-      </p:sp>
-      <p:pic>
-        <p:nvPicPr>
-          <p:cNvPr id="6" name="Asset visual-release-gate" descr="Automation accelerates delivery only after the release gate is satisfied. (mermaid diagram)"/>
-          <p:cNvPicPr>
-            <a:picLocks noChangeAspect="1"/>
-          </p:cNvPicPr>
-          <p:nvPr/>
-        </p:nvPicPr>
-        <p:blipFill>
-          <a:blip r:embed="rIdImage1"/>
-          <a:stretch>
-            <a:fillRect/>
-          </a:stretch>
-        </p:blipFill>
-        <p:spPr>
-          <a:xfrm>
-            <a:off x="5000000" y="2021875"/>
-            <a:ext cx="6500000" cy="3656250"/>
-          </a:xfrm>
-          <a:prstGeom prst="rect">
-            <a:avLst/>
-          </a:prstGeom>
-          <a:ln>
-            <a:solidFill>
-              <a:srgbClr val="D9D9D9"/>
-            </a:solidFill>
-          </a:ln>
-        </p:spPr>
-      </p:pic>
-      <p:sp>
-        <p:nvSpPr>
-          <p:cNvPr id="7" name="Footer"/>
-          <p:cNvSpPr txBox="1"/>
-          <p:nvPr/>
-        </p:nvSpPr>
-        <p:spPr>
-          <a:xfrm>
-            <a:off x="685800" y="6250000"/>
-            <a:ext cx="9400000" cy="420000"/>
+              <a:rPr lang="en-US" sz="2900" b="1">
+                <a:solidFill>
+                  <a:srgbClr val="0B121E"/>
+                </a:solidFill>
+                <a:latin typeface="+mj-lt"/>
+              </a:rPr>
+              <a:t>4.</a:t>
+            </a:r>
+            <a:r>
+              <a:rPr lang="en-US" sz="2900" b="1">
+                <a:solidFill>
+                  <a:srgbClr val="006EC3"/>
+                </a:solidFill>
+                <a:latin typeface="+mj-lt"/>
+              </a:rPr>
+              <a:t> Release gate</a:t>
+            </a:r>
+          </a:p>
+        </p:txBody>
+      </p:sp>
+      <p:sp>
+        <p:nvSpPr>
+          <p:cNvPr id="7" name="Body"/>
+          <p:cNvSpPr txBox="1"/>
+          <p:nvPr/>
+        </p:nvSpPr>
+        <p:spPr>
+          <a:xfrm>
+            <a:off x="685800" y="1950000"/>
+            <a:ext cx="3900000" cy="3900000"/>
           </a:xfrm>
           <a:prstGeom prst="rect">
             <a:avLst/>
@@ -2460,26 +2752,77 @@
               </a:spcAft>
             </a:pPr>
             <a:r>
-              <a:rPr lang="en-US" sz="1000">
-                <a:solidFill>
-                  <a:srgbClr val="BABABA"/>
-                </a:solidFill>
-              </a:rPr>
-              <a:t>Sources: Overview of application lifecycle management with Microsoft Power Platform  ·  Overview of pipelines in Power Platform  ·  Data policies</a:t>
-            </a:r>
-          </a:p>
-        </p:txBody>
-      </p:sp>
-      <p:sp>
-        <p:nvSpPr>
-          <p:cNvPr id="8" name="Slide number"/>
-          <p:cNvSpPr txBox="1"/>
-          <p:nvPr/>
-        </p:nvSpPr>
-        <p:spPr>
-          <a:xfrm>
-            <a:off x="10100000" y="6250000"/>
-            <a:ext cx="1400000" cy="420000"/>
+              <a:rPr lang="en-US" sz="2400">
+                <a:solidFill>
+                  <a:srgbClr val="0B121E"/>
+                </a:solidFill>
+              </a:rPr>
+              <a:t>Automate with pipelines, or use Azure DevOps or GitHub when the route needs it. Before final production, check DLP policy, tests, analytics, approvals and licenses.</a:t>
+            </a:r>
+          </a:p>
+        </p:txBody>
+      </p:sp>
+      <p:sp>
+        <p:nvSpPr>
+          <p:cNvPr id="8" name="Accent rule"/>
+          <p:cNvSpPr/>
+          <p:nvPr/>
+        </p:nvSpPr>
+        <p:spPr>
+          <a:xfrm>
+            <a:off x="548640" y="2000000"/>
+            <a:ext cx="45720" cy="3800000"/>
+          </a:xfrm>
+          <a:prstGeom prst="rect">
+            <a:avLst/>
+          </a:prstGeom>
+          <a:solidFill>
+            <a:srgbClr val="006EC3"/>
+          </a:solidFill>
+          <a:ln>
+            <a:noFill/>
+          </a:ln>
+        </p:spPr>
+      </p:sp>
+      <p:pic>
+        <p:nvPicPr>
+          <p:cNvPr id="9" name="Asset visual-release-gate" descr="Automation accelerates delivery only after the release gate is satisfied. (mermaid diagram)"/>
+          <p:cNvPicPr>
+            <a:picLocks noChangeAspect="1"/>
+          </p:cNvPicPr>
+          <p:nvPr/>
+        </p:nvPicPr>
+        <p:blipFill>
+          <a:blip r:embed="rIdImage1"/>
+          <a:stretch>
+            <a:fillRect/>
+          </a:stretch>
+        </p:blipFill>
+        <p:spPr>
+          <a:xfrm>
+            <a:off x="5000000" y="2221875"/>
+            <a:ext cx="6500000" cy="3656250"/>
+          </a:xfrm>
+          <a:prstGeom prst="rect">
+            <a:avLst/>
+          </a:prstGeom>
+          <a:ln>
+            <a:solidFill>
+              <a:srgbClr val="D9D9D9"/>
+            </a:solidFill>
+          </a:ln>
+        </p:spPr>
+      </p:pic>
+      <p:sp>
+        <p:nvSpPr>
+          <p:cNvPr id="10" name="Footer"/>
+          <p:cNvSpPr txBox="1"/>
+          <p:nvPr/>
+        </p:nvSpPr>
+        <p:spPr>
+          <a:xfrm>
+            <a:off x="685800" y="6250000"/>
+            <a:ext cx="10820400" cy="420000"/>
           </a:xfrm>
           <a:prstGeom prst="rect">
             <a:avLst/>
@@ -2495,14 +2838,21 @@
           </a:bodyPr>
           <a:lstStyle/>
           <a:p>
-            <a:pPr algn="r"/>
+            <a:pPr algn="l">
+              <a:lnSpc>
+                <a:spcPct val="105000"/>
+              </a:lnSpc>
+              <a:spcAft>
+                <a:spcPts val="0"/>
+              </a:spcAft>
+            </a:pPr>
             <a:r>
               <a:rPr lang="en-US" sz="1000">
                 <a:solidFill>
-                  <a:srgbClr val="BABABA"/>
-                </a:solidFill>
-              </a:rPr>
-              <a:t>5 / 6</a:t>
+                  <a:srgbClr val="64686E"/>
+                </a:solidFill>
+              </a:rPr>
+              <a:t>Sources: Overview of application lifecycle management with Microsoft Power Platform  ·  Overview of pipelines in Power Platform  ·  Data policies</a:t>
             </a:r>
           </a:p>
         </p:txBody>
@@ -2521,7 +2871,7 @@
     <p:bg>
       <p:bgPr>
         <a:solidFill>
-          <a:srgbClr val="0A0A0A"/>
+          <a:srgbClr val="F4F8FC"/>
         </a:solidFill>
         <a:effectLst/>
       </p:bgPr>
@@ -2535,20 +2885,20 @@
       <p:grpSpPr/>
       <p:sp>
         <p:nvSpPr>
-          <p:cNvPr id="2" name="Accent band"/>
+          <p:cNvPr id="2" name="Brand band"/>
           <p:cNvSpPr/>
           <p:nvPr/>
         </p:nvSpPr>
         <p:spPr>
           <a:xfrm>
             <a:off x="0" y="0"/>
-            <a:ext cx="12192000" cy="91440"/>
+            <a:ext cx="12192000" cy="502920"/>
           </a:xfrm>
           <a:prstGeom prst="rect">
             <a:avLst/>
           </a:prstGeom>
           <a:solidFill>
-            <a:srgbClr val="8F62F5"/>
+            <a:srgbClr val="0E1726"/>
           </a:solidFill>
           <a:ln>
             <a:noFill/>
@@ -2557,14 +2907,36 @@
       </p:sp>
       <p:sp>
         <p:nvSpPr>
-          <p:cNvPr id="3" name="Title"/>
-          <p:cNvSpPr txBox="1"/>
-          <p:nvPr/>
-        </p:nvSpPr>
-        <p:spPr>
-          <a:xfrm>
-            <a:off x="685800" y="420000"/>
-            <a:ext cx="10820400" cy="1000000"/>
+          <p:cNvPr id="3" name="Highlight rule"/>
+          <p:cNvSpPr/>
+          <p:nvPr/>
+        </p:nvSpPr>
+        <p:spPr>
+          <a:xfrm>
+            <a:off x="0" y="502920"/>
+            <a:ext cx="12192000" cy="45720"/>
+          </a:xfrm>
+          <a:prstGeom prst="rect">
+            <a:avLst/>
+          </a:prstGeom>
+          <a:solidFill>
+            <a:srgbClr val="B3DAF0"/>
+          </a:solidFill>
+          <a:ln>
+            <a:noFill/>
+          </a:ln>
+        </p:spPr>
+      </p:sp>
+      <p:sp>
+        <p:nvSpPr>
+          <p:cNvPr id="4" name="Deck kicker"/>
+          <p:cNvSpPr txBox="1"/>
+          <p:nvPr/>
+        </p:nvSpPr>
+        <p:spPr>
+          <a:xfrm>
+            <a:off x="685800" y="0"/>
+            <a:ext cx="8400000" cy="502920"/>
           </a:xfrm>
           <a:prstGeom prst="rect">
             <a:avLst/>
@@ -2589,45 +2961,74 @@
               </a:spcAft>
             </a:pPr>
             <a:r>
-              <a:rPr lang="en-US" sz="2400" b="1">
+              <a:rPr lang="en-US" sz="1100" b="1" cap="all" spc="120">
                 <a:solidFill>
                   <a:srgbClr val="FFFFFF"/>
                 </a:solidFill>
               </a:rPr>
-              <a:t>Sources.</a:t>
-            </a:r>
-            <a:r>
-              <a:rPr lang="en-US" sz="2400" b="1">
-                <a:solidFill>
-                  <a:srgbClr val="8F62F5"/>
-                </a:solidFill>
-              </a:rPr>
-              <a:t> Every claim traces to one.</a:t>
-            </a:r>
-          </a:p>
-        </p:txBody>
-      </p:sp>
-      <p:sp>
-        <p:nvSpPr>
-          <p:cNvPr id="4" name="Sources"/>
-          <p:cNvSpPr txBox="1"/>
-          <p:nvPr/>
-        </p:nvSpPr>
-        <p:spPr>
-          <a:xfrm>
-            <a:off x="685800" y="1700000"/>
-            <a:ext cx="10820400" cy="4300000"/>
-          </a:xfrm>
-          <a:prstGeom prst="rect">
-            <a:avLst/>
-          </a:prstGeom>
-          <a:noFill/>
-          <a:ln>
-            <a:noFill/>
-          </a:ln>
-        </p:spPr>
-        <p:txBody>
-          <a:bodyPr wrap="square" lIns="182880" tIns="91440" rIns="182880" bIns="91440" anchor="t">
+              <a:t>Power Platform ALM</a:t>
+            </a:r>
+          </a:p>
+        </p:txBody>
+      </p:sp>
+      <p:sp>
+        <p:nvSpPr>
+          <p:cNvPr id="5" name="Slide number"/>
+          <p:cNvSpPr txBox="1"/>
+          <p:nvPr/>
+        </p:nvSpPr>
+        <p:spPr>
+          <a:xfrm>
+            <a:off x="9100000" y="0"/>
+            <a:ext cx="2406400" cy="502920"/>
+          </a:xfrm>
+          <a:prstGeom prst="rect">
+            <a:avLst/>
+          </a:prstGeom>
+          <a:noFill/>
+          <a:ln>
+            <a:noFill/>
+          </a:ln>
+        </p:spPr>
+        <p:txBody>
+          <a:bodyPr wrap="square" lIns="182880" tIns="91440" rIns="182880" bIns="91440" anchor="ctr">
+            <a:normAutofit/>
+          </a:bodyPr>
+          <a:lstStyle/>
+          <a:p>
+            <a:pPr algn="r"/>
+            <a:r>
+              <a:rPr lang="en-US" sz="1100" b="1" cap="all" spc="120">
+                <a:solidFill>
+                  <a:srgbClr val="BCBEC2"/>
+                </a:solidFill>
+              </a:rPr>
+              <a:t>6 / 6</a:t>
+            </a:r>
+          </a:p>
+        </p:txBody>
+      </p:sp>
+      <p:sp>
+        <p:nvSpPr>
+          <p:cNvPr id="6" name="Title"/>
+          <p:cNvSpPr txBox="1"/>
+          <p:nvPr/>
+        </p:nvSpPr>
+        <p:spPr>
+          <a:xfrm>
+            <a:off x="685800" y="760000"/>
+            <a:ext cx="10820400" cy="1000000"/>
+          </a:xfrm>
+          <a:prstGeom prst="rect">
+            <a:avLst/>
+          </a:prstGeom>
+          <a:noFill/>
+          <a:ln>
+            <a:noFill/>
+          </a:ln>
+        </p:spPr>
+        <p:txBody>
+          <a:bodyPr wrap="square" lIns="182880" tIns="91440" rIns="182880" bIns="91440" anchor="ctr">
             <a:normAutofit/>
           </a:bodyPr>
           <a:lstStyle/>
@@ -2641,9 +3042,63 @@
               </a:spcAft>
             </a:pPr>
             <a:r>
+              <a:rPr lang="en-US" sz="2400" b="1">
+                <a:solidFill>
+                  <a:srgbClr val="0B121E"/>
+                </a:solidFill>
+                <a:latin typeface="+mj-lt"/>
+              </a:rPr>
+              <a:t>Sources.</a:t>
+            </a:r>
+            <a:r>
+              <a:rPr lang="en-US" sz="2400" b="1">
+                <a:solidFill>
+                  <a:srgbClr val="006EC3"/>
+                </a:solidFill>
+                <a:latin typeface="+mj-lt"/>
+              </a:rPr>
+              <a:t> Every claim traces to one.</a:t>
+            </a:r>
+          </a:p>
+        </p:txBody>
+      </p:sp>
+      <p:sp>
+        <p:nvSpPr>
+          <p:cNvPr id="7" name="Sources"/>
+          <p:cNvSpPr txBox="1"/>
+          <p:nvPr/>
+        </p:nvSpPr>
+        <p:spPr>
+          <a:xfrm>
+            <a:off x="685800" y="1900000"/>
+            <a:ext cx="10820400" cy="4300000"/>
+          </a:xfrm>
+          <a:prstGeom prst="rect">
+            <a:avLst/>
+          </a:prstGeom>
+          <a:noFill/>
+          <a:ln>
+            <a:noFill/>
+          </a:ln>
+        </p:spPr>
+        <p:txBody>
+          <a:bodyPr wrap="square" lIns="182880" tIns="91440" rIns="182880" bIns="91440" anchor="t">
+            <a:normAutofit/>
+          </a:bodyPr>
+          <a:lstStyle/>
+          <a:p>
+            <a:pPr algn="l">
+              <a:lnSpc>
+                <a:spcPct val="105000"/>
+              </a:lnSpc>
+              <a:spcAft>
+                <a:spcPts val="0"/>
+              </a:spcAft>
+            </a:pPr>
+            <a:r>
               <a:rPr lang="en-US" sz="1400" b="1">
                 <a:solidFill>
-                  <a:srgbClr val="FFFFFF"/>
+                  <a:srgbClr val="0B121E"/>
                 </a:solidFill>
               </a:rPr>
               <a:t>Overview of application lifecycle management with Microsoft Power Platform</a:t>
@@ -2651,7 +3106,7 @@
             <a:r>
               <a:rPr lang="en-US" sz="1100">
                 <a:solidFill>
-                  <a:srgbClr val="BABABA"/>
+                  <a:srgbClr val="64686E"/>
                 </a:solidFill>
               </a:rPr>
               <a:t>  retrieved 2026-10-06</a:t>
@@ -2669,7 +3124,7 @@
             <a:r>
               <a:rPr lang="en-US" sz="1100">
                 <a:solidFill>
-                  <a:srgbClr val="8F62F5"/>
+                  <a:srgbClr val="006EC3"/>
                 </a:solidFill>
               </a:rPr>
               <a:t>https://learn.microsoft.com/en-us/power-platform/alm/overview-alm</a:t>
@@ -2687,7 +3142,7 @@
             <a:r>
               <a:rPr lang="en-US" sz="1400" b="1">
                 <a:solidFill>
-                  <a:srgbClr val="FFFFFF"/>
+                  <a:srgbClr val="0B121E"/>
                 </a:solidFill>
               </a:rPr>
               <a:t>Solution concepts</a:t>
@@ -2695,7 +3150,7 @@
             <a:r>
               <a:rPr lang="en-US" sz="1100">
                 <a:solidFill>
-                  <a:srgbClr val="BABABA"/>
+                  <a:srgbClr val="64686E"/>
                 </a:solidFill>
               </a:rPr>
               <a:t>  retrieved 2026-10-06</a:t>
@@ -2713,7 +3168,7 @@
             <a:r>
               <a:rPr lang="en-US" sz="1100">
                 <a:solidFill>
-                  <a:srgbClr val="8F62F5"/>
+                  <a:srgbClr val="006EC3"/>
                 </a:solidFill>
               </a:rPr>
               <a:t>https://learn.microsoft.com/en-us/power-platform/alm/solution-concepts-alm</a:t>
@@ -2731,7 +3186,7 @@
             <a:r>
               <a:rPr lang="en-US" sz="1400" b="1">
                 <a:solidFill>
-                  <a:srgbClr val="FFFFFF"/>
+                  <a:srgbClr val="0B121E"/>
                 </a:solidFill>
               </a:rPr>
               <a:t>Overview of pipelines in Power Platform</a:t>
@@ -2739,7 +3194,7 @@
             <a:r>
               <a:rPr lang="en-US" sz="1100">
                 <a:solidFill>
-                  <a:srgbClr val="BABABA"/>
+                  <a:srgbClr val="64686E"/>
                 </a:solidFill>
               </a:rPr>
               <a:t>  retrieved 2026-10-06</a:t>
@@ -2757,7 +3212,7 @@
             <a:r>
               <a:rPr lang="en-US" sz="1100">
                 <a:solidFill>
-                  <a:srgbClr val="8F62F5"/>
+                  <a:srgbClr val="006EC3"/>
                 </a:solidFill>
               </a:rPr>
               <a:t>https://learn.microsoft.com/en-us/power-platform/alm/pipelines</a:t>
@@ -2775,7 +3230,7 @@
             <a:r>
               <a:rPr lang="en-US" sz="1400" b="1">
                 <a:solidFill>
-                  <a:srgbClr val="FFFFFF"/>
+                  <a:srgbClr val="0B121E"/>
                 </a:solidFill>
               </a:rPr>
               <a:t>Data policies</a:t>
@@ -2783,7 +3238,7 @@
             <a:r>
               <a:rPr lang="en-US" sz="1100">
                 <a:solidFill>
-                  <a:srgbClr val="BABABA"/>
+                  <a:srgbClr val="64686E"/>
                 </a:solidFill>
               </a:rPr>
               <a:t>  retrieved 2026-10-06</a:t>
@@ -2801,7 +3256,7 @@
             <a:r>
               <a:rPr lang="en-US" sz="1100">
                 <a:solidFill>
-                  <a:srgbClr val="8F62F5"/>
+                  <a:srgbClr val="006EC3"/>
                 </a:solidFill>
               </a:rPr>
               <a:t>https://learn.microsoft.com/en-us/power-platform/admin/wp-data-loss-prevention</a:t>
@@ -2811,14 +3266,14 @@
       </p:sp>
       <p:sp>
         <p:nvSpPr>
-          <p:cNvPr id="5" name="Footer"/>
+          <p:cNvPr id="8" name="Footer"/>
           <p:cNvSpPr txBox="1"/>
           <p:nvPr/>
         </p:nvSpPr>
         <p:spPr>
           <a:xfrm>
             <a:off x="685800" y="6250000"/>
-            <a:ext cx="9400000" cy="420000"/>
+            <a:ext cx="10820400" cy="420000"/>
           </a:xfrm>
           <a:prstGeom prst="rect">
             <a:avLst/>
@@ -2845,47 +3300,10 @@
             <a:r>
               <a:rPr lang="en-US" sz="1000">
                 <a:solidFill>
-                  <a:srgbClr val="BABABA"/>
-                </a:solidFill>
-              </a:rPr>
-              <a:t>power-platform-2026-09-am-michael-kokoro-onnx</a:t>
-            </a:r>
-          </a:p>
-        </p:txBody>
-      </p:sp>
-      <p:sp>
-        <p:nvSpPr>
-          <p:cNvPr id="6" name="Slide number"/>
-          <p:cNvSpPr txBox="1"/>
-          <p:nvPr/>
-        </p:nvSpPr>
-        <p:spPr>
-          <a:xfrm>
-            <a:off x="10100000" y="6250000"/>
-            <a:ext cx="1400000" cy="420000"/>
-          </a:xfrm>
-          <a:prstGeom prst="rect">
-            <a:avLst/>
-          </a:prstGeom>
-          <a:noFill/>
-          <a:ln>
-            <a:noFill/>
-          </a:ln>
-        </p:spPr>
-        <p:txBody>
-          <a:bodyPr wrap="square" lIns="182880" tIns="91440" rIns="182880" bIns="91440" anchor="t">
-            <a:normAutofit/>
-          </a:bodyPr>
-          <a:lstStyle/>
-          <a:p>
-            <a:pPr algn="r"/>
-            <a:r>
-              <a:rPr lang="en-US" sz="1000">
-                <a:solidFill>
-                  <a:srgbClr val="BABABA"/>
-                </a:solidFill>
-              </a:rPr>
-              <a:t>6 / 6</a:t>
+                  <a:srgbClr val="64686E"/>
+                </a:solidFill>
+              </a:rPr>
+              <a:t>power-platform-2026-10-am-michael-kokoro-onnx</a:t>
             </a:r>
           </a:p>
         </p:txBody>
@@ -2899,59 +3317,59 @@
 </file>
 
 <file path=ppt/theme/theme1.xml><?xml version="1.0" encoding="utf-8"?>
-<a:theme xmlns:a="http://schemas.openxmlformats.org/drawingml/2006/main" name="dark-violet-executive">
+<a:theme xmlns:a="http://schemas.openxmlformats.org/drawingml/2006/main" name="power-platform-2026-brand">
   <a:themeElements>
-    <a:clrScheme name="dark-violet-executive">
+    <a:clrScheme name="power-platform-2026-brand">
       <a:dk1>
-        <a:srgbClr val="FFFFFF"/>
+        <a:srgbClr val="0B121E"/>
       </a:dk1>
       <a:lt1>
-        <a:srgbClr val="0A0A0A"/>
+        <a:srgbClr val="F4F8FC"/>
       </a:lt1>
       <a:dk2>
-        <a:srgbClr val="1F1F1F"/>
+        <a:srgbClr val="0E1726"/>
       </a:dk2>
       <a:lt2>
-        <a:srgbClr val="F8F8F8"/>
+        <a:srgbClr val="E6F1F9"/>
       </a:lt2>
       <a:accent1>
-        <a:srgbClr val="8F62F5"/>
+        <a:srgbClr val="006EC3"/>
       </a:accent1>
       <a:accent2>
-        <a:srgbClr val="5B9BD5"/>
+        <a:srgbClr val="B3DAF0"/>
       </a:accent2>
       <a:accent3>
-        <a:srgbClr val="70AD47"/>
+        <a:srgbClr val="006EC3"/>
       </a:accent3>
       <a:accent4>
-        <a:srgbClr val="FFC000"/>
+        <a:srgbClr val="090F19"/>
       </a:accent4>
       <a:accent5>
-        <a:srgbClr val="C00000"/>
+        <a:srgbClr val="64686E"/>
       </a:accent5>
       <a:accent6>
-        <a:srgbClr val="7030A0"/>
+        <a:srgbClr val="B42318"/>
       </a:accent6>
       <a:hlink>
-        <a:srgbClr val="8F62F5"/>
+        <a:srgbClr val="006EC3"/>
       </a:hlink>
       <a:folHlink>
-        <a:srgbClr val="7F7F7F"/>
+        <a:srgbClr val="64686E"/>
       </a:folHlink>
     </a:clrScheme>
-    <a:fontScheme name="dark-violet-executive">
+    <a:fontScheme name="power-platform-2026-brand">
       <a:majorFont>
-        <a:latin typeface="Arial"/>
+        <a:latin typeface="Segoe UI Variable Display"/>
         <a:ea typeface=""/>
         <a:cs typeface=""/>
       </a:majorFont>
       <a:minorFont>
-        <a:latin typeface="Arial"/>
+        <a:latin typeface="Segoe UI Variable Text"/>
         <a:ea typeface=""/>
         <a:cs typeface=""/>
       </a:minorFont>
     </a:fontScheme>
-    <a:fmtScheme name="dark-violet-executive">
+    <a:fmtScheme name="power-platform-2026-brand">
       <a:fillStyleLst>
         <a:solidFill>
           <a:schemeClr val="phClr"/>

</xml_diff>

<commit_message>
feat: regenerate power-platform-2026 on media adapter 13
- render four voices with source-seeded Excalidraw strokes
- add video and spatial spectrograms and internal/external alignment evidence

🎨 - Generated by Copilot

Co-authored-by: Copilot <223556219+Copilot@users.noreply.github.com>
</commit_message>
<xml_diff>
--- a/projects/power-platform-2026/release/outputs/deck.pptx
+++ b/projects/power-platform-2026/release/outputs/deck.pptx
@@ -1476,7 +1476,7 @@
                   <a:srgbClr val="64686E"/>
                 </a:solidFill>
               </a:rPr>
-              <a:t>power-platform-2026-10-am-michael-kokoro-onnx</a:t>
+              <a:t>power-platform-2026-11-am-michael-kokoro-onnx</a:t>
             </a:r>
           </a:p>
         </p:txBody>
@@ -3303,7 +3303,7 @@
                   <a:srgbClr val="64686E"/>
                 </a:solidFill>
               </a:rPr>
-              <a:t>power-platform-2026-10-am-michael-kokoro-onnx</a:t>
+              <a:t>power-platform-2026-11-am-michael-kokoro-onnx</a:t>
             </a:r>
           </a:p>
         </p:txBody>

</xml_diff>